<commit_message>
Additional Stuffs were added
</commit_message>
<xml_diff>
--- a/SIHPPT.pptx
+++ b/SIHPPT.pptx
@@ -261,7 +261,7 @@
             <a:fld id="{C4D5ADD5-2BBC-4A94-8F86-D9013941F742}" type="datetimeFigureOut">
               <a:rPr lang="en-US"/>
               <a:pPr/>
-              <a:t>9/19/2024</a:t>
+              <a:t>9/23/2024</a:t>
             </a:fld>
             <a:endParaRPr lang="en-US"/>
           </a:p>
@@ -1534,7 +1534,7 @@
           <a:p>
             <a:fld id="{E60792E3-D524-454C-8AFD-A91972900BCB}" type="datetime1">
               <a:rPr lang="en-US" smtClean="0"/>
-              <a:t>9/19/2024</a:t>
+              <a:t>9/23/2024</a:t>
             </a:fld>
             <a:endParaRPr lang="en-US"/>
           </a:p>
@@ -1716,7 +1716,7 @@
           <a:p>
             <a:fld id="{053C3A68-6922-42D3-8905-ECC2D82A3469}" type="datetime1">
               <a:rPr lang="en-US" smtClean="0"/>
-              <a:t>9/19/2024</a:t>
+              <a:t>9/23/2024</a:t>
             </a:fld>
             <a:endParaRPr lang="en-US"/>
           </a:p>
@@ -1908,7 +1908,7 @@
           <a:p>
             <a:fld id="{CB69E9F4-7604-4950-A8B2-8ACDEDB1506E}" type="datetime1">
               <a:rPr lang="en-US" smtClean="0"/>
-              <a:t>9/19/2024</a:t>
+              <a:t>9/23/2024</a:t>
             </a:fld>
             <a:endParaRPr lang="en-US"/>
           </a:p>
@@ -2090,7 +2090,7 @@
           <a:p>
             <a:fld id="{708B7524-32A2-4C20-A58C-BC3BAA1042FC}" type="datetime1">
               <a:rPr lang="en-US" smtClean="0"/>
-              <a:t>9/19/2024</a:t>
+              <a:t>9/23/2024</a:t>
             </a:fld>
             <a:endParaRPr lang="en-US"/>
           </a:p>
@@ -2349,7 +2349,7 @@
           <a:p>
             <a:fld id="{1E994447-D6B2-43BB-A877-57F1A267B999}" type="datetime1">
               <a:rPr lang="en-US" smtClean="0"/>
-              <a:t>9/19/2024</a:t>
+              <a:t>9/23/2024</a:t>
             </a:fld>
             <a:endParaRPr lang="en-US"/>
           </a:p>
@@ -2648,7 +2648,7 @@
           <a:p>
             <a:fld id="{68920E16-BD35-483C-AA6B-346FC7E46DEA}" type="datetime1">
               <a:rPr lang="en-US" smtClean="0"/>
-              <a:t>9/19/2024</a:t>
+              <a:t>9/23/2024</a:t>
             </a:fld>
             <a:endParaRPr lang="en-US"/>
           </a:p>
@@ -3081,7 +3081,7 @@
           <a:p>
             <a:fld id="{2FEAC6F8-5103-4FC0-A69E-5C6AE6469DA8}" type="datetime1">
               <a:rPr lang="en-US" smtClean="0"/>
-              <a:t>9/19/2024</a:t>
+              <a:t>9/23/2024</a:t>
             </a:fld>
             <a:endParaRPr lang="en-US"/>
           </a:p>
@@ -3212,7 +3212,7 @@
           <a:p>
             <a:fld id="{C60C6921-0627-4C8F-83D5-0CF936D2FFDD}" type="datetime1">
               <a:rPr lang="en-US" smtClean="0"/>
-              <a:t>9/19/2024</a:t>
+              <a:t>9/23/2024</a:t>
             </a:fld>
             <a:endParaRPr lang="en-US"/>
           </a:p>
@@ -3321,7 +3321,7 @@
           <a:p>
             <a:fld id="{2FF08AD7-8103-40F8-983C-E2BA6BB9CBE0}" type="datetime1">
               <a:rPr lang="en-US" smtClean="0"/>
-              <a:t>9/19/2024</a:t>
+              <a:t>9/23/2024</a:t>
             </a:fld>
             <a:endParaRPr lang="en-US"/>
           </a:p>
@@ -3610,7 +3610,7 @@
           <a:p>
             <a:fld id="{DF8C06B4-9380-4A4D-AF49-A3596E17DAF5}" type="datetime1">
               <a:rPr lang="en-US" smtClean="0"/>
-              <a:t>9/19/2024</a:t>
+              <a:t>9/23/2024</a:t>
             </a:fld>
             <a:endParaRPr lang="en-US"/>
           </a:p>
@@ -3879,7 +3879,7 @@
           <a:p>
             <a:fld id="{EF7FDEF1-C582-4E22-9E77-D68326471F28}" type="datetime1">
               <a:rPr lang="en-US" smtClean="0"/>
-              <a:t>9/19/2024</a:t>
+              <a:t>9/23/2024</a:t>
             </a:fld>
             <a:endParaRPr lang="en-US"/>
           </a:p>
@@ -4122,7 +4122,7 @@
           <a:p>
             <a:fld id="{780A9602-A9A9-453F-AEF1-37B5837E02CD}" type="datetime1">
               <a:rPr lang="en-US" smtClean="0"/>
-              <a:t>9/19/2024</a:t>
+              <a:t>9/23/2024</a:t>
             </a:fld>
             <a:endParaRPr lang="en-US"/>
           </a:p>
@@ -6147,6 +6147,12 @@
               <a:t>Utilizing </a:t>
             </a:r>
             <a:r>
+              <a:rPr lang="en-US" sz="1900" b="1" dirty="0">
+                <a:latin typeface="+mj-lt"/>
+              </a:rPr>
+              <a:t>3D </a:t>
+            </a:r>
+            <a:r>
               <a:rPr kumimoji="0" lang="en-US" altLang="en-US" sz="1900" b="1" i="0" u="none" strike="noStrike" cap="none" normalizeH="0" baseline="0" dirty="0">
                 <a:ln>
                   <a:noFill/>
@@ -6327,7 +6333,7 @@
               <a:rPr lang="en-US" sz="1900" dirty="0">
                 <a:latin typeface="+mj-lt"/>
               </a:rPr>
-              <a:t> to ensure seamless scalability.</a:t>
+              <a:t> to ensure seamless scalability. (future work)</a:t>
             </a:r>
           </a:p>
         </p:txBody>
@@ -6572,7 +6578,7 @@
         <p:spPr>
           <a:xfrm>
             <a:off x="6371301" y="3924749"/>
-            <a:ext cx="5329084" cy="1877437"/>
+            <a:ext cx="5329084" cy="2169825"/>
           </a:xfrm>
           <a:prstGeom prst="rect">
             <a:avLst/>
@@ -6632,7 +6638,19 @@
               <a:rPr lang="en-US" sz="1900" dirty="0">
                 <a:latin typeface="+mj-lt"/>
               </a:rPr>
-              <a:t> Brain Tumor Segmentation, Classification, and RAG-Based Patient Support System.</a:t>
+              <a:t> Brain Tumor Segmentation, Classification</a:t>
+            </a:r>
+          </a:p>
+          <a:p>
+            <a:pPr marL="342900" indent="-342900" algn="just">
+              <a:buFont typeface="Wingdings" panose="05000000000000000000" pitchFamily="2" charset="2"/>
+              <a:buChar char="Ø"/>
+            </a:pPr>
+            <a:r>
+              <a:rPr lang="en-US" sz="1900" dirty="0">
+                <a:latin typeface="+mj-lt"/>
+              </a:rPr>
+              <a:t>RAG-Based Patient Support System.</a:t>
             </a:r>
             <a:endParaRPr lang="en-US" sz="1900" b="1" dirty="0">
               <a:solidFill>
@@ -6662,15 +6680,16 @@
                 </a:solidFill>
                 <a:latin typeface="+mj-lt"/>
               </a:rPr>
-              <a:t>Encryption</a:t>
+              <a:t>Encryption </a:t>
             </a:r>
             <a:r>
               <a:rPr lang="en-US" sz="1900" dirty="0">
                 <a:solidFill>
                   <a:schemeClr val="tx1"/>
                 </a:solidFill>
-              </a:rPr>
-              <a:t>.</a:t>
+                <a:latin typeface="+mj-lt"/>
+              </a:rPr>
+              <a:t>for the user’s input data(future work)</a:t>
             </a:r>
           </a:p>
         </p:txBody>
@@ -7101,7 +7120,7 @@
                 <a:ea typeface="Calibri" panose="020F0502020204030204" pitchFamily="34" charset="0"/>
                 <a:cs typeface="Calibri" panose="020F0502020204030204" pitchFamily="34" charset="0"/>
               </a:rPr>
-              <a:t>for robust data encryption in the chatbot, ensuring secure communication</a:t>
+              <a:t>for robust data encryption in the chatbot, ensuring secure communication(future work)</a:t>
             </a:r>
           </a:p>
           <a:p>
@@ -7150,7 +7169,7 @@
                 <a:ea typeface="Calibri" panose="020F0502020204030204" pitchFamily="34" charset="0"/>
                 <a:cs typeface="Calibri" panose="020F0502020204030204" pitchFamily="34" charset="0"/>
               </a:rPr>
-              <a:t> for chatbot.</a:t>
+              <a:t> for chatbot.(future work)</a:t>
             </a:r>
           </a:p>
           <a:p>

</xml_diff>